<commit_message>
Executive summary formatting, ppt updates
</commit_message>
<xml_diff>
--- a/projects/01-primalityTests/slides/Primality_Tests.pptx
+++ b/projects/01-primalityTests/slides/Primality_Tests.pptx
@@ -4,6 +4,9 @@
   <p:sldMasterIdLst>
     <p:sldMasterId id="2147483738" r:id="rId1"/>
   </p:sldMasterIdLst>
+  <p:notesMasterIdLst>
+    <p:notesMasterId r:id="rId17"/>
+  </p:notesMasterIdLst>
   <p:sldIdLst>
     <p:sldId id="256" r:id="rId2"/>
     <p:sldId id="257" r:id="rId3"/>
@@ -118,6 +121,11 @@
       </a:defRPr>
     </a:lvl9pPr>
   </p:defaultTextStyle>
+  <p:extLst>
+    <p:ext uri="{EFAFB233-063F-42B5-8137-9DF3F51BA10A}">
+      <p15:sldGuideLst xmlns:p15="http://schemas.microsoft.com/office/powerpoint/2012/main"/>
+    </p:ext>
+  </p:extLst>
 </p:presentation>
 </file>
 
@@ -125,8 +133,643 @@
 <p1510:revInfo xmlns:a="http://schemas.openxmlformats.org/drawingml/2006/main" xmlns:r="http://schemas.openxmlformats.org/officeDocument/2006/relationships" xmlns:p1510="http://schemas.microsoft.com/office/powerpoint/2015/10/main">
   <p1510:revLst>
     <p1510:client id="{0289EFED-96BF-4AFE-8E8E-695AEB67A800}" v="161" dt="2026-04-21T01:19:44.175"/>
+    <p1510:client id="{F8CA59A4-A002-1969-E3C8-0A6CE4C4F0D4}" v="171" dt="2026-04-21T06:31:53.831"/>
   </p1510:revLst>
 </p1510:revInfo>
+</file>
+
+<file path=ppt/notesMasters/notesMaster1.xml><?xml version="1.0" encoding="utf-8"?>
+<p:notesMaster xmlns:a="http://schemas.openxmlformats.org/drawingml/2006/main" xmlns:r="http://schemas.openxmlformats.org/officeDocument/2006/relationships" xmlns:p="http://schemas.openxmlformats.org/presentationml/2006/main">
+  <p:cSld>
+    <p:bg>
+      <p:bgRef idx="1001">
+        <a:schemeClr val="bg1"/>
+      </p:bgRef>
+    </p:bg>
+    <p:spTree>
+      <p:nvGrpSpPr>
+        <p:cNvPr id="1" name=""/>
+        <p:cNvGrpSpPr/>
+        <p:nvPr/>
+      </p:nvGrpSpPr>
+      <p:grpSpPr>
+        <a:xfrm>
+          <a:off x="0" y="0"/>
+          <a:ext cx="0" cy="0"/>
+          <a:chOff x="0" y="0"/>
+          <a:chExt cx="0" cy="0"/>
+        </a:xfrm>
+      </p:grpSpPr>
+      <p:sp>
+        <p:nvSpPr>
+          <p:cNvPr id="2" name="Header Placeholder 1"/>
+          <p:cNvSpPr>
+            <a:spLocks noGrp="1"/>
+          </p:cNvSpPr>
+          <p:nvPr>
+            <p:ph type="hdr" sz="quarter"/>
+          </p:nvPr>
+        </p:nvSpPr>
+        <p:spPr>
+          <a:xfrm>
+            <a:off x="0" y="0"/>
+            <a:ext cx="2971800" cy="458788"/>
+          </a:xfrm>
+          <a:prstGeom prst="rect">
+            <a:avLst/>
+          </a:prstGeom>
+        </p:spPr>
+        <p:txBody>
+          <a:bodyPr vert="horz" lIns="91440" tIns="45720" rIns="91440" bIns="45720" rtlCol="0"/>
+          <a:lstStyle>
+            <a:lvl1pPr algn="l">
+              <a:defRPr sz="1200"/>
+            </a:lvl1pPr>
+          </a:lstStyle>
+          <a:p>
+            <a:endParaRPr lang="en-US"/>
+          </a:p>
+        </p:txBody>
+      </p:sp>
+      <p:sp>
+        <p:nvSpPr>
+          <p:cNvPr id="3" name="Date Placeholder 2"/>
+          <p:cNvSpPr>
+            <a:spLocks noGrp="1"/>
+          </p:cNvSpPr>
+          <p:nvPr>
+            <p:ph type="dt" idx="1"/>
+          </p:nvPr>
+        </p:nvSpPr>
+        <p:spPr>
+          <a:xfrm>
+            <a:off x="3884613" y="0"/>
+            <a:ext cx="2971800" cy="458788"/>
+          </a:xfrm>
+          <a:prstGeom prst="rect">
+            <a:avLst/>
+          </a:prstGeom>
+        </p:spPr>
+        <p:txBody>
+          <a:bodyPr vert="horz" lIns="91440" tIns="45720" rIns="91440" bIns="45720" rtlCol="0"/>
+          <a:lstStyle>
+            <a:lvl1pPr algn="r">
+              <a:defRPr sz="1200"/>
+            </a:lvl1pPr>
+          </a:lstStyle>
+          <a:p>
+            <a:fld id="{0EB341E0-9823-493F-886D-FCF1D33B7AEA}" type="datetimeFigureOut">
+              <a:t>4/20/2026</a:t>
+            </a:fld>
+            <a:endParaRPr lang="en-US"/>
+          </a:p>
+        </p:txBody>
+      </p:sp>
+      <p:sp>
+        <p:nvSpPr>
+          <p:cNvPr id="4" name="Slide Image Placeholder 3"/>
+          <p:cNvSpPr>
+            <a:spLocks noGrp="1" noRot="1" noChangeAspect="1"/>
+          </p:cNvSpPr>
+          <p:nvPr>
+            <p:ph type="sldImg" idx="2"/>
+          </p:nvPr>
+        </p:nvSpPr>
+        <p:spPr>
+          <a:xfrm>
+            <a:off x="685800" y="1143000"/>
+            <a:ext cx="5486400" cy="3086100"/>
+          </a:xfrm>
+          <a:prstGeom prst="rect">
+            <a:avLst/>
+          </a:prstGeom>
+          <a:noFill/>
+          <a:ln w="12700">
+            <a:solidFill>
+              <a:prstClr val="black"/>
+            </a:solidFill>
+          </a:ln>
+        </p:spPr>
+        <p:txBody>
+          <a:bodyPr vert="horz" lIns="91440" tIns="45720" rIns="91440" bIns="45720" rtlCol="0" anchor="ctr"/>
+          <a:lstStyle/>
+          <a:p>
+            <a:endParaRPr lang="en-US"/>
+          </a:p>
+        </p:txBody>
+      </p:sp>
+      <p:sp>
+        <p:nvSpPr>
+          <p:cNvPr id="5" name="Notes Placeholder 4"/>
+          <p:cNvSpPr>
+            <a:spLocks noGrp="1"/>
+          </p:cNvSpPr>
+          <p:nvPr>
+            <p:ph type="body" sz="quarter" idx="3"/>
+          </p:nvPr>
+        </p:nvSpPr>
+        <p:spPr>
+          <a:xfrm>
+            <a:off x="685800" y="4400550"/>
+            <a:ext cx="5486400" cy="3600450"/>
+          </a:xfrm>
+          <a:prstGeom prst="rect">
+            <a:avLst/>
+          </a:prstGeom>
+        </p:spPr>
+        <p:txBody>
+          <a:bodyPr vert="horz" lIns="91440" tIns="45720" rIns="91440" bIns="45720" rtlCol="0"/>
+          <a:lstStyle/>
+          <a:p>
+            <a:pPr lvl="0"/>
+            <a:r>
+              <a:rPr lang="en-US"/>
+              <a:t>Click to edit Master text styles</a:t>
+            </a:r>
+          </a:p>
+          <a:p>
+            <a:pPr lvl="1"/>
+            <a:r>
+              <a:rPr lang="en-US"/>
+              <a:t>Second level</a:t>
+            </a:r>
+          </a:p>
+          <a:p>
+            <a:pPr lvl="2"/>
+            <a:r>
+              <a:rPr lang="en-US"/>
+              <a:t>Third level</a:t>
+            </a:r>
+          </a:p>
+          <a:p>
+            <a:pPr lvl="3"/>
+            <a:r>
+              <a:rPr lang="en-US"/>
+              <a:t>Fourth level</a:t>
+            </a:r>
+          </a:p>
+          <a:p>
+            <a:pPr lvl="4"/>
+            <a:r>
+              <a:rPr lang="en-US"/>
+              <a:t>Fifth level</a:t>
+            </a:r>
+          </a:p>
+        </p:txBody>
+      </p:sp>
+      <p:sp>
+        <p:nvSpPr>
+          <p:cNvPr id="6" name="Footer Placeholder 5"/>
+          <p:cNvSpPr>
+            <a:spLocks noGrp="1"/>
+          </p:cNvSpPr>
+          <p:nvPr>
+            <p:ph type="ftr" sz="quarter" idx="4"/>
+          </p:nvPr>
+        </p:nvSpPr>
+        <p:spPr>
+          <a:xfrm>
+            <a:off x="0" y="8685213"/>
+            <a:ext cx="2971800" cy="458787"/>
+          </a:xfrm>
+          <a:prstGeom prst="rect">
+            <a:avLst/>
+          </a:prstGeom>
+        </p:spPr>
+        <p:txBody>
+          <a:bodyPr vert="horz" lIns="91440" tIns="45720" rIns="91440" bIns="45720" rtlCol="0" anchor="b"/>
+          <a:lstStyle>
+            <a:lvl1pPr algn="l">
+              <a:defRPr sz="1200"/>
+            </a:lvl1pPr>
+          </a:lstStyle>
+          <a:p>
+            <a:endParaRPr lang="en-US"/>
+          </a:p>
+        </p:txBody>
+      </p:sp>
+      <p:sp>
+        <p:nvSpPr>
+          <p:cNvPr id="7" name="Slide Number Placeholder 6"/>
+          <p:cNvSpPr>
+            <a:spLocks noGrp="1"/>
+          </p:cNvSpPr>
+          <p:nvPr>
+            <p:ph type="sldNum" sz="quarter" idx="5"/>
+          </p:nvPr>
+        </p:nvSpPr>
+        <p:spPr>
+          <a:xfrm>
+            <a:off x="3884613" y="8685213"/>
+            <a:ext cx="2971800" cy="458787"/>
+          </a:xfrm>
+          <a:prstGeom prst="rect">
+            <a:avLst/>
+          </a:prstGeom>
+        </p:spPr>
+        <p:txBody>
+          <a:bodyPr vert="horz" lIns="91440" tIns="45720" rIns="91440" bIns="45720" rtlCol="0" anchor="b"/>
+          <a:lstStyle>
+            <a:lvl1pPr algn="r">
+              <a:defRPr sz="1200"/>
+            </a:lvl1pPr>
+          </a:lstStyle>
+          <a:p>
+            <a:fld id="{6463D987-8A1A-4AF4-936A-FDDE1C151732}" type="slidenum">
+              <a:t>‹#›</a:t>
+            </a:fld>
+            <a:endParaRPr lang="en-US"/>
+          </a:p>
+        </p:txBody>
+      </p:sp>
+    </p:spTree>
+    <p:extLst>
+      <p:ext uri="{BB962C8B-B14F-4D97-AF65-F5344CB8AC3E}">
+        <p14:creationId xmlns:p14="http://schemas.microsoft.com/office/powerpoint/2010/main" val="1214747607"/>
+      </p:ext>
+    </p:extLst>
+  </p:cSld>
+  <p:clrMap bg1="lt1" tx1="dk1" bg2="lt2" tx2="dk2" accent1="accent1" accent2="accent2" accent3="accent3" accent4="accent4" accent5="accent5" accent6="accent6" hlink="hlink" folHlink="folHlink"/>
+  <p:notesStyle>
+    <a:lvl1pPr marL="0" algn="l" defTabSz="914400" rtl="0" eaLnBrk="1" latinLnBrk="0" hangingPunct="1">
+      <a:defRPr sz="1200" kern="1200">
+        <a:solidFill>
+          <a:schemeClr val="tx1"/>
+        </a:solidFill>
+        <a:latin typeface="+mn-lt"/>
+        <a:ea typeface="+mn-ea"/>
+        <a:cs typeface="+mn-cs"/>
+      </a:defRPr>
+    </a:lvl1pPr>
+    <a:lvl2pPr marL="457200" algn="l" defTabSz="914400" rtl="0" eaLnBrk="1" latinLnBrk="0" hangingPunct="1">
+      <a:defRPr sz="1200" kern="1200">
+        <a:solidFill>
+          <a:schemeClr val="tx1"/>
+        </a:solidFill>
+        <a:latin typeface="+mn-lt"/>
+        <a:ea typeface="+mn-ea"/>
+        <a:cs typeface="+mn-cs"/>
+      </a:defRPr>
+    </a:lvl2pPr>
+    <a:lvl3pPr marL="914400" algn="l" defTabSz="914400" rtl="0" eaLnBrk="1" latinLnBrk="0" hangingPunct="1">
+      <a:defRPr sz="1200" kern="1200">
+        <a:solidFill>
+          <a:schemeClr val="tx1"/>
+        </a:solidFill>
+        <a:latin typeface="+mn-lt"/>
+        <a:ea typeface="+mn-ea"/>
+        <a:cs typeface="+mn-cs"/>
+      </a:defRPr>
+    </a:lvl3pPr>
+    <a:lvl4pPr marL="1371600" algn="l" defTabSz="914400" rtl="0" eaLnBrk="1" latinLnBrk="0" hangingPunct="1">
+      <a:defRPr sz="1200" kern="1200">
+        <a:solidFill>
+          <a:schemeClr val="tx1"/>
+        </a:solidFill>
+        <a:latin typeface="+mn-lt"/>
+        <a:ea typeface="+mn-ea"/>
+        <a:cs typeface="+mn-cs"/>
+      </a:defRPr>
+    </a:lvl4pPr>
+    <a:lvl5pPr marL="1828800" algn="l" defTabSz="914400" rtl="0" eaLnBrk="1" latinLnBrk="0" hangingPunct="1">
+      <a:defRPr sz="1200" kern="1200">
+        <a:solidFill>
+          <a:schemeClr val="tx1"/>
+        </a:solidFill>
+        <a:latin typeface="+mn-lt"/>
+        <a:ea typeface="+mn-ea"/>
+        <a:cs typeface="+mn-cs"/>
+      </a:defRPr>
+    </a:lvl5pPr>
+    <a:lvl6pPr marL="2286000" algn="l" defTabSz="914400" rtl="0" eaLnBrk="1" latinLnBrk="0" hangingPunct="1">
+      <a:defRPr sz="1200" kern="1200">
+        <a:solidFill>
+          <a:schemeClr val="tx1"/>
+        </a:solidFill>
+        <a:latin typeface="+mn-lt"/>
+        <a:ea typeface="+mn-ea"/>
+        <a:cs typeface="+mn-cs"/>
+      </a:defRPr>
+    </a:lvl6pPr>
+    <a:lvl7pPr marL="2743200" algn="l" defTabSz="914400" rtl="0" eaLnBrk="1" latinLnBrk="0" hangingPunct="1">
+      <a:defRPr sz="1200" kern="1200">
+        <a:solidFill>
+          <a:schemeClr val="tx1"/>
+        </a:solidFill>
+        <a:latin typeface="+mn-lt"/>
+        <a:ea typeface="+mn-ea"/>
+        <a:cs typeface="+mn-cs"/>
+      </a:defRPr>
+    </a:lvl7pPr>
+    <a:lvl8pPr marL="3200400" algn="l" defTabSz="914400" rtl="0" eaLnBrk="1" latinLnBrk="0" hangingPunct="1">
+      <a:defRPr sz="1200" kern="1200">
+        <a:solidFill>
+          <a:schemeClr val="tx1"/>
+        </a:solidFill>
+        <a:latin typeface="+mn-lt"/>
+        <a:ea typeface="+mn-ea"/>
+        <a:cs typeface="+mn-cs"/>
+      </a:defRPr>
+    </a:lvl8pPr>
+    <a:lvl9pPr marL="3657600" algn="l" defTabSz="914400" rtl="0" eaLnBrk="1" latinLnBrk="0" hangingPunct="1">
+      <a:defRPr sz="1200" kern="1200">
+        <a:solidFill>
+          <a:schemeClr val="tx1"/>
+        </a:solidFill>
+        <a:latin typeface="+mn-lt"/>
+        <a:ea typeface="+mn-ea"/>
+        <a:cs typeface="+mn-cs"/>
+      </a:defRPr>
+    </a:lvl9pPr>
+  </p:notesStyle>
+</p:notesMaster>
+</file>
+
+<file path=ppt/notesSlides/notesSlide1.xml><?xml version="1.0" encoding="utf-8"?>
+<p:notes xmlns:a="http://schemas.openxmlformats.org/drawingml/2006/main" xmlns:r="http://schemas.openxmlformats.org/officeDocument/2006/relationships" xmlns:p="http://schemas.openxmlformats.org/presentationml/2006/main">
+  <p:cSld>
+    <p:spTree>
+      <p:nvGrpSpPr>
+        <p:cNvPr id="1" name=""/>
+        <p:cNvGrpSpPr/>
+        <p:nvPr/>
+      </p:nvGrpSpPr>
+      <p:grpSpPr>
+        <a:xfrm>
+          <a:off x="0" y="0"/>
+          <a:ext cx="0" cy="0"/>
+          <a:chOff x="0" y="0"/>
+          <a:chExt cx="0" cy="0"/>
+        </a:xfrm>
+      </p:grpSpPr>
+      <p:sp>
+        <p:nvSpPr>
+          <p:cNvPr id="2" name="Slide Image Placeholder 1"/>
+          <p:cNvSpPr>
+            <a:spLocks noGrp="1" noRot="1" noChangeAspect="1"/>
+          </p:cNvSpPr>
+          <p:nvPr>
+            <p:ph type="sldImg"/>
+          </p:nvPr>
+        </p:nvSpPr>
+        <p:spPr/>
+      </p:sp>
+      <p:sp>
+        <p:nvSpPr>
+          <p:cNvPr id="3" name="Notes Placeholder 2"/>
+          <p:cNvSpPr>
+            <a:spLocks noGrp="1"/>
+          </p:cNvSpPr>
+          <p:nvPr>
+            <p:ph type="body" idx="1"/>
+          </p:nvPr>
+        </p:nvSpPr>
+        <p:spPr/>
+        <p:txBody>
+          <a:bodyPr/>
+          <a:lstStyle/>
+          <a:p>
+            <a:r>
+              <a:rPr lang="en-US" dirty="0">
+                <a:ea typeface="Calibri"/>
+                <a:cs typeface="Calibri"/>
+              </a:rPr>
+              <a:t>Carmichael numbers are the only case where</a:t>
+            </a:r>
+            <a:r>
+              <a:rPr lang="en-US">
+                <a:ea typeface="Calibri"/>
+                <a:cs typeface="Calibri"/>
+              </a:rPr>
+              <a:t> the strict inverse of Fermat's Little Theorem does not hold.</a:t>
+            </a:r>
+            <a:endParaRPr lang="en-US" dirty="0"/>
+          </a:p>
+          <a:p>
+            <a:endParaRPr lang="en-US" dirty="0">
+              <a:ea typeface="Calibri" panose="020F0502020204030204"/>
+              <a:cs typeface="Calibri" panose="020F0502020204030204"/>
+            </a:endParaRPr>
+          </a:p>
+          <a:p>
+            <a:r>
+              <a:rPr lang="en-US" dirty="0">
+                <a:ea typeface="Calibri" panose="020F0502020204030204"/>
+                <a:cs typeface="Calibri" panose="020F0502020204030204"/>
+              </a:rPr>
+              <a:t>In order to find it with </a:t>
+            </a:r>
+            <a:r>
+              <a:rPr lang="en-US" dirty="0" err="1">
+                <a:ea typeface="Calibri" panose="020F0502020204030204"/>
+                <a:cs typeface="Calibri" panose="020F0502020204030204"/>
+              </a:rPr>
+              <a:t>fermat's</a:t>
+            </a:r>
+            <a:r>
+              <a:rPr lang="en-US" dirty="0">
+                <a:ea typeface="Calibri" panose="020F0502020204030204"/>
+                <a:cs typeface="Calibri" panose="020F0502020204030204"/>
+              </a:rPr>
+              <a:t> primality test, you have to pick a base that is not coprime with n. If you want to detect 561, you have to pick a b that has 3, 11, or 17 as a factor.</a:t>
+            </a:r>
+          </a:p>
+          <a:p>
+            <a:endParaRPr lang="en-US" dirty="0"/>
+          </a:p>
+          <a:p>
+            <a:r>
+              <a:rPr lang="en-US" dirty="0"/>
+              <a:t>As numbers become larger, Carmichael numbers become increasingly rare. For example, there are 20138200 Carmichael numbers between 1 and 10^</a:t>
+            </a:r>
+            <a:r>
+              <a:rPr lang="en-US" baseline="30000" dirty="0"/>
+              <a:t>21</a:t>
+            </a:r>
+            <a:r>
+              <a:rPr lang="en-US" dirty="0"/>
+              <a:t> (approximately one in 50 trillion (5×10</a:t>
+            </a:r>
+            <a:r>
+              <a:rPr lang="en-US" baseline="30000" dirty="0"/>
+              <a:t>13</a:t>
+            </a:r>
+            <a:r>
+              <a:rPr lang="en-US" dirty="0"/>
+              <a:t>) numbers). 1 in 48 numbers with 21 digits are actually prime, so </a:t>
+            </a:r>
+            <a:r>
+              <a:rPr lang="en-US" dirty="0" err="1"/>
+              <a:t>carmichael</a:t>
+            </a:r>
+            <a:r>
+              <a:rPr lang="en-US" dirty="0"/>
+              <a:t> numbers are exceedingly rare.</a:t>
+            </a:r>
+            <a:endParaRPr lang="en-US" dirty="0">
+              <a:ea typeface="Calibri" panose="020F0502020204030204"/>
+              <a:cs typeface="Calibri" panose="020F0502020204030204"/>
+            </a:endParaRPr>
+          </a:p>
+          <a:p>
+            <a:endParaRPr lang="en-US" dirty="0">
+              <a:ea typeface="Calibri" panose="020F0502020204030204"/>
+              <a:cs typeface="Calibri" panose="020F0502020204030204"/>
+            </a:endParaRPr>
+          </a:p>
+          <a:p>
+            <a:r>
+              <a:rPr lang="en-US" dirty="0">
+                <a:ea typeface="Calibri" panose="020F0502020204030204"/>
+                <a:cs typeface="Calibri" panose="020F0502020204030204"/>
+              </a:rPr>
+              <a:t>The other problem with this test is consistency. Outside of Carmichael numbers, there is no guarantee of the probability of a composite number passing a round of the </a:t>
+            </a:r>
+            <a:r>
+              <a:rPr lang="en-US" dirty="0" err="1">
+                <a:ea typeface="Calibri" panose="020F0502020204030204"/>
+                <a:cs typeface="Calibri" panose="020F0502020204030204"/>
+              </a:rPr>
+              <a:t>fermat</a:t>
+            </a:r>
+            <a:r>
+              <a:rPr lang="en-US" dirty="0">
+                <a:ea typeface="Calibri" panose="020F0502020204030204"/>
+                <a:cs typeface="Calibri" panose="020F0502020204030204"/>
+              </a:rPr>
+              <a:t> test.</a:t>
+            </a:r>
+          </a:p>
+          <a:p>
+            <a:endParaRPr lang="en-US" dirty="0">
+              <a:ea typeface="Calibri" panose="020F0502020204030204"/>
+              <a:cs typeface="Calibri" panose="020F0502020204030204"/>
+            </a:endParaRPr>
+          </a:p>
+        </p:txBody>
+      </p:sp>
+      <p:sp>
+        <p:nvSpPr>
+          <p:cNvPr id="4" name="Slide Number Placeholder 3"/>
+          <p:cNvSpPr>
+            <a:spLocks noGrp="1"/>
+          </p:cNvSpPr>
+          <p:nvPr>
+            <p:ph type="sldNum" sz="quarter" idx="5"/>
+          </p:nvPr>
+        </p:nvSpPr>
+        <p:spPr/>
+        <p:txBody>
+          <a:bodyPr/>
+          <a:lstStyle/>
+          <a:p>
+            <a:fld id="{6463D987-8A1A-4AF4-936A-FDDE1C151732}" type="slidenum">
+              <a:t>8</a:t>
+            </a:fld>
+            <a:endParaRPr lang="en-US"/>
+          </a:p>
+        </p:txBody>
+      </p:sp>
+    </p:spTree>
+    <p:extLst>
+      <p:ext uri="{BB962C8B-B14F-4D97-AF65-F5344CB8AC3E}">
+        <p14:creationId xmlns:p14="http://schemas.microsoft.com/office/powerpoint/2010/main" val="1335191926"/>
+      </p:ext>
+    </p:extLst>
+  </p:cSld>
+  <p:clrMapOvr>
+    <a:masterClrMapping/>
+  </p:clrMapOvr>
+</p:notes>
+</file>
+
+<file path=ppt/notesSlides/notesSlide2.xml><?xml version="1.0" encoding="utf-8"?>
+<p:notes xmlns:a="http://schemas.openxmlformats.org/drawingml/2006/main" xmlns:r="http://schemas.openxmlformats.org/officeDocument/2006/relationships" xmlns:p="http://schemas.openxmlformats.org/presentationml/2006/main">
+  <p:cSld>
+    <p:spTree>
+      <p:nvGrpSpPr>
+        <p:cNvPr id="1" name=""/>
+        <p:cNvGrpSpPr/>
+        <p:nvPr/>
+      </p:nvGrpSpPr>
+      <p:grpSpPr>
+        <a:xfrm>
+          <a:off x="0" y="0"/>
+          <a:ext cx="0" cy="0"/>
+          <a:chOff x="0" y="0"/>
+          <a:chExt cx="0" cy="0"/>
+        </a:xfrm>
+      </p:grpSpPr>
+      <p:sp>
+        <p:nvSpPr>
+          <p:cNvPr id="2" name="Slide Image Placeholder 1"/>
+          <p:cNvSpPr>
+            <a:spLocks noGrp="1" noRot="1" noChangeAspect="1"/>
+          </p:cNvSpPr>
+          <p:nvPr>
+            <p:ph type="sldImg"/>
+          </p:nvPr>
+        </p:nvSpPr>
+        <p:spPr/>
+      </p:sp>
+      <p:sp>
+        <p:nvSpPr>
+          <p:cNvPr id="3" name="Notes Placeholder 2"/>
+          <p:cNvSpPr>
+            <a:spLocks noGrp="1"/>
+          </p:cNvSpPr>
+          <p:nvPr>
+            <p:ph type="body" idx="1"/>
+          </p:nvPr>
+        </p:nvSpPr>
+        <p:spPr/>
+        <p:txBody>
+          <a:bodyPr/>
+          <a:lstStyle/>
+          <a:p>
+            <a:r>
+              <a:rPr lang="en-US">
+                <a:ea typeface="Calibri"/>
+                <a:cs typeface="Calibri"/>
+              </a:rPr>
+              <a:t>For any prime number greater than 2, we can rewrite n-1 as 2^s * d, where d is odd</a:t>
+            </a:r>
+          </a:p>
+        </p:txBody>
+      </p:sp>
+      <p:sp>
+        <p:nvSpPr>
+          <p:cNvPr id="4" name="Slide Number Placeholder 3"/>
+          <p:cNvSpPr>
+            <a:spLocks noGrp="1"/>
+          </p:cNvSpPr>
+          <p:nvPr>
+            <p:ph type="sldNum" sz="quarter" idx="5"/>
+          </p:nvPr>
+        </p:nvSpPr>
+        <p:spPr/>
+        <p:txBody>
+          <a:bodyPr/>
+          <a:lstStyle/>
+          <a:p>
+            <a:fld id="{6463D987-8A1A-4AF4-936A-FDDE1C151732}" type="slidenum">
+              <a:t>9</a:t>
+            </a:fld>
+            <a:endParaRPr lang="en-US"/>
+          </a:p>
+        </p:txBody>
+      </p:sp>
+    </p:spTree>
+    <p:extLst>
+      <p:ext uri="{BB962C8B-B14F-4D97-AF65-F5344CB8AC3E}">
+        <p14:creationId xmlns:p14="http://schemas.microsoft.com/office/powerpoint/2010/main" val="2289455690"/>
+      </p:ext>
+    </p:extLst>
+  </p:cSld>
+  <p:clrMapOvr>
+    <a:masterClrMapping/>
+  </p:clrMapOvr>
+</p:notes>
 </file>
 
 <file path=ppt/slideLayouts/slideLayout1.xml><?xml version="1.0" encoding="utf-8"?>
@@ -7609,7 +8252,9 @@
           </a:xfrm>
         </p:spPr>
         <p:txBody>
-          <a:bodyPr/>
+          <a:bodyPr vert="horz" lIns="91440" tIns="45720" rIns="91440" bIns="45720" rtlCol="0" anchor="t">
+            <a:normAutofit/>
+          </a:bodyPr>
           <a:lstStyle/>
           <a:p>
             <a:r>
@@ -7618,7 +8263,7 @@
             </a:r>
             <a:r>
               <a:rPr lang="en-US"/>
-              <a:t>– a number which is only divisible evenly by itself and 1</a:t>
+              <a:t>– a number which is only divisible by itself and 1</a:t>
             </a:r>
             <a:endParaRPr lang="en-US" b="1"/>
           </a:p>
@@ -7627,19 +8272,19 @@
           </a:p>
           <a:p>
             <a:r>
-              <a:rPr lang="en-US" b="1"/>
+              <a:rPr lang="en-US" b="1" dirty="0"/>
               <a:t>Our goal: </a:t>
             </a:r>
             <a:r>
-              <a:rPr lang="en-US"/>
+              <a:rPr lang="en-US" dirty="0"/>
               <a:t>given a number </a:t>
             </a:r>
             <a:r>
-              <a:rPr lang="en-US" i="1"/>
+              <a:rPr lang="en-US" i="1" dirty="0"/>
               <a:t>n</a:t>
             </a:r>
             <a:r>
-              <a:rPr lang="en-US"/>
+              <a:rPr lang="en-US" dirty="0"/>
               <a:t>, determine if it is prime in a way that is both fast and accurate</a:t>
             </a:r>
           </a:p>
@@ -8304,7 +8949,7 @@
           <a:lstStyle/>
           <a:p>
             <a:r>
-              <a:rPr lang="en-US"/>
+              <a:rPr lang="en-US" dirty="0"/>
               <a:t>Fermat's Little Theorem states that for all prime numbers p and integers a, </a:t>
             </a:r>
           </a:p>
@@ -8331,14 +8976,19 @@
               </a:buClr>
             </a:pPr>
             <a:r>
-              <a:rPr lang="en-US"/>
-              <a:t>You can divide this formulation by a (when a&lt;=p-1) on both sides to get:</a:t>
+              <a:rPr lang="en-US" dirty="0"/>
+              <a:t>You can divide this formulation by a (when </a:t>
+            </a:r>
+            <a:r>
+              <a:rPr lang="en-US" dirty="0" err="1"/>
+              <a:t>gcd</a:t>
+            </a:r>
+            <a:r>
+              <a:rPr lang="en-US" dirty="0"/>
+              <a:t>(a, p) = 1) on both sides to get:</a:t>
             </a:r>
             <a:br>
-              <a:rPr lang="en-US"/>
-            </a:br>
-            <a:br>
-              <a:rPr lang="en-US"/>
+              <a:rPr lang="en-US" dirty="0"/>
             </a:br>
             <a:endParaRPr lang="en-US"/>
           </a:p>
@@ -8348,7 +8998,7 @@
                 <a:srgbClr val="8AD0D6"/>
               </a:buClr>
             </a:pPr>
-            <a:endParaRPr lang="en-US"/>
+            <a:endParaRPr lang="en-US" dirty="0"/>
           </a:p>
           <a:p>
             <a:pPr>
@@ -8361,10 +9011,10 @@
               <a:t>When a number fails Fermat's Little Theorem, we know it is not prime. Proving that a number is prime is more difficult</a:t>
             </a:r>
             <a:br>
-              <a:rPr lang="en-US"/>
+              <a:rPr lang="en-US" dirty="0"/>
             </a:br>
             <a:br>
-              <a:rPr lang="en-US"/>
+              <a:rPr lang="en-US" dirty="0"/>
             </a:br>
             <a:endParaRPr lang="en-US"/>
           </a:p>
@@ -8422,7 +9072,7 @@
         </p:blipFill>
         <p:spPr>
           <a:xfrm>
-            <a:off x="1442508" y="4418542"/>
+            <a:off x="1433543" y="4149601"/>
             <a:ext cx="2533650" cy="476250"/>
           </a:xfrm>
           <a:prstGeom prst="rect">
@@ -8430,8 +9080,8 @@
           </a:prstGeom>
         </p:spPr>
       </p:pic>
-      <mc:AlternateContent xmlns:mc="http://schemas.openxmlformats.org/markup-compatibility/2006">
-        <mc:Choice xmlns:a14="http://schemas.microsoft.com/office/drawing/2010/main" Requires="a14">
+      <mc:AlternateContent xmlns:mc="http://schemas.openxmlformats.org/markup-compatibility/2006" xmlns:a14="http://schemas.microsoft.com/office/drawing/2010/main">
+        <mc:Choice Requires="a14">
           <p:sp>
             <p:nvSpPr>
               <p:cNvPr id="8" name="TextBox 7">
@@ -8518,12 +9168,12 @@
                     </m:oMath>
                   </m:oMathPara>
                 </a14:m>
-                <a:endParaRPr lang="en-US" dirty="0"/>
+                <a:endParaRPr lang="en-US"/>
               </a:p>
             </p:txBody>
           </p:sp>
         </mc:Choice>
-        <mc:Fallback>
+        <mc:Fallback xmlns="">
           <p:sp>
             <p:nvSpPr>
               <p:cNvPr id="8" name="TextBox 7">
@@ -8597,14 +9247,14 @@
           <a:lstStyle/>
           <a:p>
             <a:r>
-              <a:rPr lang="en-US" dirty="0"/>
+              <a:rPr lang="en-US"/>
               <a:t>means</a:t>
             </a:r>
           </a:p>
         </p:txBody>
       </p:sp>
-      <mc:AlternateContent xmlns:mc="http://schemas.openxmlformats.org/markup-compatibility/2006">
-        <mc:Choice xmlns:a14="http://schemas.microsoft.com/office/drawing/2010/main" Requires="a14">
+      <mc:AlternateContent xmlns:mc="http://schemas.openxmlformats.org/markup-compatibility/2006" xmlns:a14="http://schemas.microsoft.com/office/drawing/2010/main">
+        <mc:Choice Requires="a14">
           <p:sp>
             <p:nvSpPr>
               <p:cNvPr id="7" name="TextBox 6">
@@ -8633,6 +9283,7 @@
               </a:bodyPr>
               <a:lstStyle/>
               <a:p>
+                <a:pPr/>
                 <a14:m>
                   <m:oMathPara xmlns:m="http://schemas.openxmlformats.org/officeDocument/2006/math">
                     <m:oMathParaPr>
@@ -8672,12 +9323,12 @@
                     </m:oMath>
                   </m:oMathPara>
                 </a14:m>
-                <a:endParaRPr lang="en-US" dirty="0"/>
+                <a:endParaRPr lang="en-US"/>
               </a:p>
             </p:txBody>
           </p:sp>
         </mc:Choice>
-        <mc:Fallback>
+        <mc:Fallback xmlns="">
           <p:sp>
             <p:nvSpPr>
               <p:cNvPr id="7" name="TextBox 6">
@@ -9060,7 +9711,7 @@
         </p:spPr>
         <p:txBody>
           <a:bodyPr vert="horz" lIns="91440" tIns="45720" rIns="91440" bIns="45720" rtlCol="0" anchor="t">
-            <a:normAutofit/>
+            <a:normAutofit lnSpcReduction="10000"/>
           </a:bodyPr>
           <a:lstStyle/>
           <a:p>
@@ -9139,8 +9790,12 @@
               <a:t>O(log n)</a:t>
             </a:r>
             <a:r>
-              <a:rPr lang="en-US"/>
-              <a:t> multiplications</a:t>
+              <a:rPr lang="en-US" dirty="0"/>
+              <a:t> </a:t>
+            </a:r>
+            <a:r>
+              <a:rPr lang="en-US"/>
+              <a:t>multiplications</a:t>
             </a:r>
           </a:p>
           <a:p>
@@ -9195,8 +9850,28 @@
             </a:pPr>
             <a:r>
               <a:rPr lang="en-US"/>
-              <a:t>Product of at least 3 prime numbers</a:t>
-            </a:r>
+              <a:t>                                      for all coprime b and n.</a:t>
+            </a:r>
+            <a:endParaRPr lang="en-US" dirty="0"/>
+          </a:p>
+          <a:p>
+            <a:pPr marL="457200" lvl="1" indent="0">
+              <a:buClr>
+                <a:srgbClr val="8AD0D6"/>
+              </a:buClr>
+              <a:buNone/>
+            </a:pPr>
+            <a:r>
+              <a:rPr lang="en-US">
+                <a:ea typeface="+mj-lt"/>
+                <a:cs typeface="+mj-lt"/>
+              </a:rPr>
+              <a:t>   =&gt; n has no repeated prime factors, and </a:t>
+            </a:r>
+            <a:endParaRPr lang="en-US" dirty="0">
+              <a:ea typeface="+mj-lt"/>
+              <a:cs typeface="+mj-lt"/>
+            </a:endParaRPr>
           </a:p>
           <a:p>
             <a:pPr lvl="1">
@@ -9237,6 +9912,66 @@
           </a:p>
         </p:txBody>
       </p:sp>
+      <p:pic>
+        <p:nvPicPr>
+          <p:cNvPr id="5" name="Picture 4">
+            <a:extLst>
+              <a:ext uri="{FF2B5EF4-FFF2-40B4-BE49-F238E27FC236}">
+                <a16:creationId xmlns:a16="http://schemas.microsoft.com/office/drawing/2014/main" id="{F9C4204F-CD6D-D30C-AC4C-70C9241C33B6}"/>
+              </a:ext>
+            </a:extLst>
+          </p:cNvPr>
+          <p:cNvPicPr>
+            <a:picLocks noChangeAspect="1"/>
+          </p:cNvPicPr>
+          <p:nvPr/>
+        </p:nvPicPr>
+        <p:blipFill>
+          <a:blip r:embed="rId3"/>
+          <a:stretch>
+            <a:fillRect/>
+          </a:stretch>
+        </p:blipFill>
+        <p:spPr>
+          <a:xfrm>
+            <a:off x="1826110" y="4721128"/>
+            <a:ext cx="2437144" cy="396282"/>
+          </a:xfrm>
+          <a:prstGeom prst="rect">
+            <a:avLst/>
+          </a:prstGeom>
+        </p:spPr>
+      </p:pic>
+      <p:pic>
+        <p:nvPicPr>
+          <p:cNvPr id="8" name="Picture 7" descr="A close up of a letter&#10;&#10;AI-generated content may be incorrect.">
+            <a:extLst>
+              <a:ext uri="{FF2B5EF4-FFF2-40B4-BE49-F238E27FC236}">
+                <a16:creationId xmlns:a16="http://schemas.microsoft.com/office/drawing/2014/main" id="{0C1CFACE-65C5-A7DC-083F-C05B54F290A1}"/>
+              </a:ext>
+            </a:extLst>
+          </p:cNvPr>
+          <p:cNvPicPr>
+            <a:picLocks noChangeAspect="1"/>
+          </p:cNvPicPr>
+          <p:nvPr/>
+        </p:nvPicPr>
+        <p:blipFill>
+          <a:blip r:embed="rId4"/>
+          <a:stretch>
+            <a:fillRect/>
+          </a:stretch>
+        </p:blipFill>
+        <p:spPr>
+          <a:xfrm>
+            <a:off x="6510390" y="5115972"/>
+            <a:ext cx="2922605" cy="385815"/>
+          </a:xfrm>
+          <a:prstGeom prst="rect">
+            <a:avLst/>
+          </a:prstGeom>
+        </p:spPr>
+      </p:pic>
     </p:spTree>
     <p:extLst>
       <p:ext uri="{BB962C8B-B14F-4D97-AF65-F5344CB8AC3E}">
@@ -9382,35 +10117,7 @@
                 <a:ea typeface="+mj-lt"/>
                 <a:cs typeface="+mj-lt"/>
               </a:rPr>
-              <a:t> is odd</a:t>
-            </a:r>
-            <a:r>
-              <a:rPr lang="en-US" i="1">
-                <a:ea typeface="+mj-lt"/>
-                <a:cs typeface="+mj-lt"/>
-              </a:rPr>
-              <a:t>  </a:t>
-            </a:r>
-            <a:r>
-              <a:rPr lang="en-US">
-                <a:ea typeface="+mj-lt"/>
-                <a:cs typeface="+mj-lt"/>
-              </a:rPr>
-              <a:t>(</a:t>
-            </a:r>
-            <a:r>
-              <a:rPr lang="en-US" i="1">
-                <a:ea typeface="+mj-lt"/>
-                <a:cs typeface="+mj-lt"/>
-              </a:rPr>
-              <a:t>n – 1</a:t>
-            </a:r>
-            <a:r>
-              <a:rPr lang="en-US">
-                <a:ea typeface="+mj-lt"/>
-                <a:cs typeface="+mj-lt"/>
-              </a:rPr>
-              <a:t> will be even for any prime number greater than 2), then factorize</a:t>
+              <a:t> is odd, then factorize</a:t>
             </a:r>
           </a:p>
           <a:p>
@@ -9514,7 +10221,7 @@
           <p:nvPr/>
         </p:nvPicPr>
         <p:blipFill>
-          <a:blip r:embed="rId2"/>
+          <a:blip r:embed="rId3"/>
           <a:stretch>
             <a:fillRect/>
           </a:stretch>
@@ -9808,6 +10515,301 @@
 </a:theme>
 </file>
 
+<file path=ppt/theme/theme2.xml><?xml version="1.0" encoding="utf-8"?>
+<a:theme xmlns:a="http://schemas.openxmlformats.org/drawingml/2006/main" name="Office Theme">
+  <a:themeElements>
+    <a:clrScheme name="Office">
+      <a:dk1>
+        <a:sysClr val="windowText" lastClr="000000"/>
+      </a:dk1>
+      <a:lt1>
+        <a:sysClr val="window" lastClr="FFFFFF"/>
+      </a:lt1>
+      <a:dk2>
+        <a:srgbClr val="44546A"/>
+      </a:dk2>
+      <a:lt2>
+        <a:srgbClr val="E7E6E6"/>
+      </a:lt2>
+      <a:accent1>
+        <a:srgbClr val="4472C4"/>
+      </a:accent1>
+      <a:accent2>
+        <a:srgbClr val="ED7D31"/>
+      </a:accent2>
+      <a:accent3>
+        <a:srgbClr val="A5A5A5"/>
+      </a:accent3>
+      <a:accent4>
+        <a:srgbClr val="FFC000"/>
+      </a:accent4>
+      <a:accent5>
+        <a:srgbClr val="5B9BD5"/>
+      </a:accent5>
+      <a:accent6>
+        <a:srgbClr val="70AD47"/>
+      </a:accent6>
+      <a:hlink>
+        <a:srgbClr val="0563C1"/>
+      </a:hlink>
+      <a:folHlink>
+        <a:srgbClr val="954F72"/>
+      </a:folHlink>
+    </a:clrScheme>
+    <a:fontScheme name="Office">
+      <a:majorFont>
+        <a:latin typeface="Calibri Light" panose="020F0302020204030204"/>
+        <a:ea typeface=""/>
+        <a:cs typeface=""/>
+        <a:font script="Jpan" typeface="游ゴシック Light"/>
+        <a:font script="Hang" typeface="맑은 고딕"/>
+        <a:font script="Hans" typeface="等线 Light"/>
+        <a:font script="Hant" typeface="新細明體"/>
+        <a:font script="Arab" typeface="Times New Roman"/>
+        <a:font script="Hebr" typeface="Times New Roman"/>
+        <a:font script="Thai" typeface="Angsana New"/>
+        <a:font script="Ethi" typeface="Nyala"/>
+        <a:font script="Beng" typeface="Vrinda"/>
+        <a:font script="Gujr" typeface="Shruti"/>
+        <a:font script="Khmr" typeface="MoolBoran"/>
+        <a:font script="Knda" typeface="Tunga"/>
+        <a:font script="Guru" typeface="Raavi"/>
+        <a:font script="Cans" typeface="Euphemia"/>
+        <a:font script="Cher" typeface="Plantagenet Cherokee"/>
+        <a:font script="Yiii" typeface="Microsoft Yi Baiti"/>
+        <a:font script="Tibt" typeface="Microsoft Himalaya"/>
+        <a:font script="Thaa" typeface="MV Boli"/>
+        <a:font script="Deva" typeface="Mangal"/>
+        <a:font script="Telu" typeface="Gautami"/>
+        <a:font script="Taml" typeface="Latha"/>
+        <a:font script="Syrc" typeface="Estrangelo Edessa"/>
+        <a:font script="Orya" typeface="Kalinga"/>
+        <a:font script="Mlym" typeface="Kartika"/>
+        <a:font script="Laoo" typeface="DokChampa"/>
+        <a:font script="Sinh" typeface="Iskoola Pota"/>
+        <a:font script="Mong" typeface="Mongolian Baiti"/>
+        <a:font script="Viet" typeface="Times New Roman"/>
+        <a:font script="Uigh" typeface="Microsoft Uighur"/>
+        <a:font script="Geor" typeface="Sylfaen"/>
+        <a:font script="Armn" typeface="Arial"/>
+        <a:font script="Bugi" typeface="Leelawadee UI"/>
+        <a:font script="Bopo" typeface="Microsoft JhengHei"/>
+        <a:font script="Java" typeface="Javanese Text"/>
+        <a:font script="Lisu" typeface="Segoe UI"/>
+        <a:font script="Mymr" typeface="Myanmar Text"/>
+        <a:font script="Nkoo" typeface="Ebrima"/>
+        <a:font script="Olck" typeface="Nirmala UI"/>
+        <a:font script="Osma" typeface="Ebrima"/>
+        <a:font script="Phag" typeface="Phagspa"/>
+        <a:font script="Syrn" typeface="Estrangelo Edessa"/>
+        <a:font script="Syrj" typeface="Estrangelo Edessa"/>
+        <a:font script="Syre" typeface="Estrangelo Edessa"/>
+        <a:font script="Sora" typeface="Nirmala UI"/>
+        <a:font script="Tale" typeface="Microsoft Tai Le"/>
+        <a:font script="Talu" typeface="Microsoft New Tai Lue"/>
+        <a:font script="Tfng" typeface="Ebrima"/>
+      </a:majorFont>
+      <a:minorFont>
+        <a:latin typeface="Calibri" panose="020F0502020204030204"/>
+        <a:ea typeface=""/>
+        <a:cs typeface=""/>
+        <a:font script="Jpan" typeface="游ゴシック"/>
+        <a:font script="Hang" typeface="맑은 고딕"/>
+        <a:font script="Hans" typeface="等线"/>
+        <a:font script="Hant" typeface="新細明體"/>
+        <a:font script="Arab" typeface="Arial"/>
+        <a:font script="Hebr" typeface="Arial"/>
+        <a:font script="Thai" typeface="Cordia New"/>
+        <a:font script="Ethi" typeface="Nyala"/>
+        <a:font script="Beng" typeface="Vrinda"/>
+        <a:font script="Gujr" typeface="Shruti"/>
+        <a:font script="Khmr" typeface="DaunPenh"/>
+        <a:font script="Knda" typeface="Tunga"/>
+        <a:font script="Guru" typeface="Raavi"/>
+        <a:font script="Cans" typeface="Euphemia"/>
+        <a:font script="Cher" typeface="Plantagenet Cherokee"/>
+        <a:font script="Yiii" typeface="Microsoft Yi Baiti"/>
+        <a:font script="Tibt" typeface="Microsoft Himalaya"/>
+        <a:font script="Thaa" typeface="MV Boli"/>
+        <a:font script="Deva" typeface="Mangal"/>
+        <a:font script="Telu" typeface="Gautami"/>
+        <a:font script="Taml" typeface="Latha"/>
+        <a:font script="Syrc" typeface="Estrangelo Edessa"/>
+        <a:font script="Orya" typeface="Kalinga"/>
+        <a:font script="Mlym" typeface="Kartika"/>
+        <a:font script="Laoo" typeface="DokChampa"/>
+        <a:font script="Sinh" typeface="Iskoola Pota"/>
+        <a:font script="Mong" typeface="Mongolian Baiti"/>
+        <a:font script="Viet" typeface="Arial"/>
+        <a:font script="Uigh" typeface="Microsoft Uighur"/>
+        <a:font script="Geor" typeface="Sylfaen"/>
+        <a:font script="Armn" typeface="Arial"/>
+        <a:font script="Bugi" typeface="Leelawadee UI"/>
+        <a:font script="Bopo" typeface="Microsoft JhengHei"/>
+        <a:font script="Java" typeface="Javanese Text"/>
+        <a:font script="Lisu" typeface="Segoe UI"/>
+        <a:font script="Mymr" typeface="Myanmar Text"/>
+        <a:font script="Nkoo" typeface="Ebrima"/>
+        <a:font script="Olck" typeface="Nirmala UI"/>
+        <a:font script="Osma" typeface="Ebrima"/>
+        <a:font script="Phag" typeface="Phagspa"/>
+        <a:font script="Syrn" typeface="Estrangelo Edessa"/>
+        <a:font script="Syrj" typeface="Estrangelo Edessa"/>
+        <a:font script="Syre" typeface="Estrangelo Edessa"/>
+        <a:font script="Sora" typeface="Nirmala UI"/>
+        <a:font script="Tale" typeface="Microsoft Tai Le"/>
+        <a:font script="Talu" typeface="Microsoft New Tai Lue"/>
+        <a:font script="Tfng" typeface="Ebrima"/>
+      </a:minorFont>
+    </a:fontScheme>
+    <a:fmtScheme name="Office">
+      <a:fillStyleLst>
+        <a:solidFill>
+          <a:schemeClr val="phClr"/>
+        </a:solidFill>
+        <a:gradFill rotWithShape="1">
+          <a:gsLst>
+            <a:gs pos="0">
+              <a:schemeClr val="phClr">
+                <a:lumMod val="110000"/>
+                <a:satMod val="105000"/>
+                <a:tint val="67000"/>
+              </a:schemeClr>
+            </a:gs>
+            <a:gs pos="50000">
+              <a:schemeClr val="phClr">
+                <a:lumMod val="105000"/>
+                <a:satMod val="103000"/>
+                <a:tint val="73000"/>
+              </a:schemeClr>
+            </a:gs>
+            <a:gs pos="100000">
+              <a:schemeClr val="phClr">
+                <a:lumMod val="105000"/>
+                <a:satMod val="109000"/>
+                <a:tint val="81000"/>
+              </a:schemeClr>
+            </a:gs>
+          </a:gsLst>
+          <a:lin ang="5400000" scaled="0"/>
+        </a:gradFill>
+        <a:gradFill rotWithShape="1">
+          <a:gsLst>
+            <a:gs pos="0">
+              <a:schemeClr val="phClr">
+                <a:satMod val="103000"/>
+                <a:lumMod val="102000"/>
+                <a:tint val="94000"/>
+              </a:schemeClr>
+            </a:gs>
+            <a:gs pos="50000">
+              <a:schemeClr val="phClr">
+                <a:satMod val="110000"/>
+                <a:lumMod val="100000"/>
+                <a:shade val="100000"/>
+              </a:schemeClr>
+            </a:gs>
+            <a:gs pos="100000">
+              <a:schemeClr val="phClr">
+                <a:lumMod val="99000"/>
+                <a:satMod val="120000"/>
+                <a:shade val="78000"/>
+              </a:schemeClr>
+            </a:gs>
+          </a:gsLst>
+          <a:lin ang="5400000" scaled="0"/>
+        </a:gradFill>
+      </a:fillStyleLst>
+      <a:lnStyleLst>
+        <a:ln w="6350" cap="flat" cmpd="sng" algn="ctr">
+          <a:solidFill>
+            <a:schemeClr val="phClr"/>
+          </a:solidFill>
+          <a:prstDash val="solid"/>
+          <a:miter lim="800000"/>
+        </a:ln>
+        <a:ln w="12700" cap="flat" cmpd="sng" algn="ctr">
+          <a:solidFill>
+            <a:schemeClr val="phClr"/>
+          </a:solidFill>
+          <a:prstDash val="solid"/>
+          <a:miter lim="800000"/>
+        </a:ln>
+        <a:ln w="19050" cap="flat" cmpd="sng" algn="ctr">
+          <a:solidFill>
+            <a:schemeClr val="phClr"/>
+          </a:solidFill>
+          <a:prstDash val="solid"/>
+          <a:miter lim="800000"/>
+        </a:ln>
+      </a:lnStyleLst>
+      <a:effectStyleLst>
+        <a:effectStyle>
+          <a:effectLst/>
+        </a:effectStyle>
+        <a:effectStyle>
+          <a:effectLst/>
+        </a:effectStyle>
+        <a:effectStyle>
+          <a:effectLst>
+            <a:outerShdw blurRad="57150" dist="19050" dir="5400000" algn="ctr" rotWithShape="0">
+              <a:srgbClr val="000000">
+                <a:alpha val="63000"/>
+              </a:srgbClr>
+            </a:outerShdw>
+          </a:effectLst>
+        </a:effectStyle>
+      </a:effectStyleLst>
+      <a:bgFillStyleLst>
+        <a:solidFill>
+          <a:schemeClr val="phClr"/>
+        </a:solidFill>
+        <a:solidFill>
+          <a:schemeClr val="phClr">
+            <a:tint val="95000"/>
+            <a:satMod val="170000"/>
+          </a:schemeClr>
+        </a:solidFill>
+        <a:gradFill rotWithShape="1">
+          <a:gsLst>
+            <a:gs pos="0">
+              <a:schemeClr val="phClr">
+                <a:tint val="93000"/>
+                <a:satMod val="150000"/>
+                <a:shade val="98000"/>
+                <a:lumMod val="102000"/>
+              </a:schemeClr>
+            </a:gs>
+            <a:gs pos="50000">
+              <a:schemeClr val="phClr">
+                <a:tint val="98000"/>
+                <a:satMod val="130000"/>
+                <a:shade val="90000"/>
+                <a:lumMod val="103000"/>
+              </a:schemeClr>
+            </a:gs>
+            <a:gs pos="100000">
+              <a:schemeClr val="phClr">
+                <a:shade val="63000"/>
+                <a:satMod val="120000"/>
+              </a:schemeClr>
+            </a:gs>
+          </a:gsLst>
+          <a:lin ang="5400000" scaled="0"/>
+        </a:gradFill>
+      </a:bgFillStyleLst>
+    </a:fmtScheme>
+  </a:themeElements>
+  <a:objectDefaults/>
+  <a:extraClrSchemeLst/>
+  <a:extLst>
+    <a:ext uri="{05A4C25C-085E-4340-85A3-A5531E510DB2}">
+      <thm15:themeFamily xmlns:thm15="http://schemas.microsoft.com/office/thememl/2012/main" name="Office Theme" id="{62F939B6-93AF-4DB8-9C6B-D6C7DFDC589F}" vid="{4A3C46E8-61CC-4603-A589-7422A47A8E4A}"/>
+    </a:ext>
+  </a:extLst>
+</a:theme>
+</file>
+
 <file path=ppt/webextensions/taskpanes.xml><?xml version="1.0" encoding="utf-8"?>
 <wetp:taskpanes xmlns:wetp="http://schemas.microsoft.com/office/webextensions/taskpanes/2010/11">
   <wetp:taskpane dockstate="right" visibility="0" width="350" row="0">

</xml_diff>